<commit_message>
Final deck: slide 6 wording fix + PDF export
</commit_message>
<xml_diff>
--- a/docs/presentation.pptx
+++ b/docs/presentation.pptx
@@ -5,15 +5,15 @@
     <p:sldMasterId id="2147483648" r:id="rId1"/>
   </p:sldMasterIdLst>
   <p:sldIdLst>
-    <p:sldId id="256" r:id="rId7"/>
-    <p:sldId id="257" r:id="rId8"/>
-    <p:sldId id="258" r:id="rId9"/>
-    <p:sldId id="259" r:id="rId10"/>
-    <p:sldId id="260" r:id="rId11"/>
-    <p:sldId id="261" r:id="rId12"/>
-    <p:sldId id="262" r:id="rId13"/>
+    <p:sldId id="256" r:id="rId2"/>
+    <p:sldId id="257" r:id="rId3"/>
+    <p:sldId id="258" r:id="rId4"/>
+    <p:sldId id="259" r:id="rId5"/>
+    <p:sldId id="260" r:id="rId6"/>
+    <p:sldId id="261" r:id="rId7"/>
+    <p:sldId id="262" r:id="rId8"/>
   </p:sldIdLst>
-  <p:sldSz cx="12191695" cy="6858000" type="screen4x3"/>
+  <p:sldSz cx="12192000" cy="6858000"/>
   <p:notesSz cx="6858000" cy="9144000"/>
   <p:defaultTextStyle>
     <a:defPPr>
@@ -110,6 +110,22 @@
       </a:defRPr>
     </a:lvl9pPr>
   </p:defaultTextStyle>
+  <p:extLst>
+    <p:ext uri="{EFAFB233-063F-42B5-8137-9DF3F51BA10A}">
+      <p15:sldGuideLst xmlns:p15="http://schemas.microsoft.com/office/powerpoint/2012/main">
+        <p15:guide id="1" orient="horz" pos="2160">
+          <p15:clr>
+            <a:srgbClr val="A4A3A4"/>
+          </p15:clr>
+        </p15:guide>
+        <p15:guide id="2" pos="2880">
+          <p15:clr>
+            <a:srgbClr val="A4A3A4"/>
+          </p15:clr>
+        </p15:guide>
+      </p15:sldGuideLst>
+    </p:ext>
+  </p:extLst>
 </p:presentation>
 </file>
 
@@ -151,10 +167,9 @@
           <a:lstStyle/>
           <a:p>
             <a:r>
-              <a:rPr lang="en-US" smtClean="0"/>
+              <a:rPr lang="en-US"/>
               <a:t>Click to edit Master title style</a:t>
             </a:r>
-            <a:endParaRPr lang="en-US"/>
           </a:p>
         </p:txBody>
       </p:sp>
@@ -270,10 +285,9 @@
           </a:lstStyle>
           <a:p>
             <a:r>
-              <a:rPr lang="en-US" smtClean="0"/>
+              <a:rPr lang="en-US"/>
               <a:t>Click to edit Master subtitle style</a:t>
             </a:r>
-            <a:endParaRPr lang="en-US"/>
           </a:p>
         </p:txBody>
       </p:sp>
@@ -294,7 +308,7 @@
           <a:p>
             <a:fld id="{5BCAD085-E8A6-8845-BD4E-CB4CCA059FC4}" type="datetimeFigureOut">
               <a:rPr lang="en-US" smtClean="0"/>
-              <a:t>1/27/13</a:t>
+              <a:t>10/19/2026</a:t>
             </a:fld>
             <a:endParaRPr lang="en-US"/>
           </a:p>
@@ -388,10 +402,9 @@
           <a:lstStyle/>
           <a:p>
             <a:r>
-              <a:rPr lang="en-US" smtClean="0"/>
+              <a:rPr lang="en-US"/>
               <a:t>Click to edit Master title style</a:t>
             </a:r>
-            <a:endParaRPr lang="en-US"/>
           </a:p>
         </p:txBody>
       </p:sp>
@@ -412,38 +425,37 @@
           <a:p>
             <a:pPr lvl="0"/>
             <a:r>
-              <a:rPr lang="en-US" smtClean="0"/>
+              <a:rPr lang="en-US"/>
               <a:t>Click to edit Master text styles</a:t>
             </a:r>
           </a:p>
           <a:p>
             <a:pPr lvl="1"/>
             <a:r>
-              <a:rPr lang="en-US" smtClean="0"/>
+              <a:rPr lang="en-US"/>
               <a:t>Second level</a:t>
             </a:r>
           </a:p>
           <a:p>
             <a:pPr lvl="2"/>
             <a:r>
-              <a:rPr lang="en-US" smtClean="0"/>
+              <a:rPr lang="en-US"/>
               <a:t>Third level</a:t>
             </a:r>
           </a:p>
           <a:p>
             <a:pPr lvl="3"/>
             <a:r>
-              <a:rPr lang="en-US" smtClean="0"/>
+              <a:rPr lang="en-US"/>
               <a:t>Fourth level</a:t>
             </a:r>
           </a:p>
           <a:p>
             <a:pPr lvl="4"/>
             <a:r>
-              <a:rPr lang="en-US" smtClean="0"/>
+              <a:rPr lang="en-US"/>
               <a:t>Fifth level</a:t>
             </a:r>
-            <a:endParaRPr lang="en-US"/>
           </a:p>
         </p:txBody>
       </p:sp>
@@ -464,7 +476,7 @@
           <a:p>
             <a:fld id="{5BCAD085-E8A6-8845-BD4E-CB4CCA059FC4}" type="datetimeFigureOut">
               <a:rPr lang="en-US" smtClean="0"/>
-              <a:t>1/27/13</a:t>
+              <a:t>10/19/2026</a:t>
             </a:fld>
             <a:endParaRPr lang="en-US"/>
           </a:p>
@@ -563,10 +575,9 @@
           <a:lstStyle/>
           <a:p>
             <a:r>
-              <a:rPr lang="en-US" smtClean="0"/>
+              <a:rPr lang="en-US"/>
               <a:t>Click to edit Master title style</a:t>
             </a:r>
-            <a:endParaRPr lang="en-US"/>
           </a:p>
         </p:txBody>
       </p:sp>
@@ -592,38 +603,37 @@
           <a:p>
             <a:pPr lvl="0"/>
             <a:r>
-              <a:rPr lang="en-US" smtClean="0"/>
+              <a:rPr lang="en-US"/>
               <a:t>Click to edit Master text styles</a:t>
             </a:r>
           </a:p>
           <a:p>
             <a:pPr lvl="1"/>
             <a:r>
-              <a:rPr lang="en-US" smtClean="0"/>
+              <a:rPr lang="en-US"/>
               <a:t>Second level</a:t>
             </a:r>
           </a:p>
           <a:p>
             <a:pPr lvl="2"/>
             <a:r>
-              <a:rPr lang="en-US" smtClean="0"/>
+              <a:rPr lang="en-US"/>
               <a:t>Third level</a:t>
             </a:r>
           </a:p>
           <a:p>
             <a:pPr lvl="3"/>
             <a:r>
-              <a:rPr lang="en-US" smtClean="0"/>
+              <a:rPr lang="en-US"/>
               <a:t>Fourth level</a:t>
             </a:r>
           </a:p>
           <a:p>
             <a:pPr lvl="4"/>
             <a:r>
-              <a:rPr lang="en-US" smtClean="0"/>
+              <a:rPr lang="en-US"/>
               <a:t>Fifth level</a:t>
             </a:r>
-            <a:endParaRPr lang="en-US"/>
           </a:p>
         </p:txBody>
       </p:sp>
@@ -644,7 +654,7 @@
           <a:p>
             <a:fld id="{5BCAD085-E8A6-8845-BD4E-CB4CCA059FC4}" type="datetimeFigureOut">
               <a:rPr lang="en-US" smtClean="0"/>
-              <a:t>1/27/13</a:t>
+              <a:t>10/19/2026</a:t>
             </a:fld>
             <a:endParaRPr lang="en-US"/>
           </a:p>
@@ -738,10 +748,9 @@
           <a:lstStyle/>
           <a:p>
             <a:r>
-              <a:rPr lang="en-US" smtClean="0"/>
+              <a:rPr lang="en-US"/>
               <a:t>Click to edit Master title style</a:t>
             </a:r>
-            <a:endParaRPr lang="en-US"/>
           </a:p>
         </p:txBody>
       </p:sp>
@@ -762,38 +771,37 @@
           <a:p>
             <a:pPr lvl="0"/>
             <a:r>
-              <a:rPr lang="en-US" smtClean="0"/>
+              <a:rPr lang="en-US"/>
               <a:t>Click to edit Master text styles</a:t>
             </a:r>
           </a:p>
           <a:p>
             <a:pPr lvl="1"/>
             <a:r>
-              <a:rPr lang="en-US" smtClean="0"/>
+              <a:rPr lang="en-US"/>
               <a:t>Second level</a:t>
             </a:r>
           </a:p>
           <a:p>
             <a:pPr lvl="2"/>
             <a:r>
-              <a:rPr lang="en-US" smtClean="0"/>
+              <a:rPr lang="en-US"/>
               <a:t>Third level</a:t>
             </a:r>
           </a:p>
           <a:p>
             <a:pPr lvl="3"/>
             <a:r>
-              <a:rPr lang="en-US" smtClean="0"/>
+              <a:rPr lang="en-US"/>
               <a:t>Fourth level</a:t>
             </a:r>
           </a:p>
           <a:p>
             <a:pPr lvl="4"/>
             <a:r>
-              <a:rPr lang="en-US" smtClean="0"/>
+              <a:rPr lang="en-US"/>
               <a:t>Fifth level</a:t>
             </a:r>
-            <a:endParaRPr lang="en-US"/>
           </a:p>
         </p:txBody>
       </p:sp>
@@ -814,7 +822,7 @@
           <a:p>
             <a:fld id="{5BCAD085-E8A6-8845-BD4E-CB4CCA059FC4}" type="datetimeFigureOut">
               <a:rPr lang="en-US" smtClean="0"/>
-              <a:t>1/27/13</a:t>
+              <a:t>10/19/2026</a:t>
             </a:fld>
             <a:endParaRPr lang="en-US"/>
           </a:p>
@@ -917,10 +925,9 @@
           </a:lstStyle>
           <a:p>
             <a:r>
-              <a:rPr lang="en-US" smtClean="0"/>
+              <a:rPr lang="en-US"/>
               <a:t>Click to edit Master title style</a:t>
             </a:r>
-            <a:endParaRPr lang="en-US"/>
           </a:p>
         </p:txBody>
       </p:sp>
@@ -1037,7 +1044,7 @@
           <a:p>
             <a:pPr lvl="0"/>
             <a:r>
-              <a:rPr lang="en-US" smtClean="0"/>
+              <a:rPr lang="en-US"/>
               <a:t>Click to edit Master text styles</a:t>
             </a:r>
           </a:p>
@@ -1060,7 +1067,7 @@
           <a:p>
             <a:fld id="{5BCAD085-E8A6-8845-BD4E-CB4CCA059FC4}" type="datetimeFigureOut">
               <a:rPr lang="en-US" smtClean="0"/>
-              <a:t>1/27/13</a:t>
+              <a:t>10/19/2026</a:t>
             </a:fld>
             <a:endParaRPr lang="en-US"/>
           </a:p>
@@ -1154,10 +1161,9 @@
           <a:lstStyle/>
           <a:p>
             <a:r>
-              <a:rPr lang="en-US" smtClean="0"/>
+              <a:rPr lang="en-US"/>
               <a:t>Click to edit Master title style</a:t>
             </a:r>
-            <a:endParaRPr lang="en-US"/>
           </a:p>
         </p:txBody>
       </p:sp>
@@ -1211,38 +1217,37 @@
           <a:p>
             <a:pPr lvl="0"/>
             <a:r>
-              <a:rPr lang="en-US" smtClean="0"/>
+              <a:rPr lang="en-US"/>
               <a:t>Click to edit Master text styles</a:t>
             </a:r>
           </a:p>
           <a:p>
             <a:pPr lvl="1"/>
             <a:r>
-              <a:rPr lang="en-US" smtClean="0"/>
+              <a:rPr lang="en-US"/>
               <a:t>Second level</a:t>
             </a:r>
           </a:p>
           <a:p>
             <a:pPr lvl="2"/>
             <a:r>
-              <a:rPr lang="en-US" smtClean="0"/>
+              <a:rPr lang="en-US"/>
               <a:t>Third level</a:t>
             </a:r>
           </a:p>
           <a:p>
             <a:pPr lvl="3"/>
             <a:r>
-              <a:rPr lang="en-US" smtClean="0"/>
+              <a:rPr lang="en-US"/>
               <a:t>Fourth level</a:t>
             </a:r>
           </a:p>
           <a:p>
             <a:pPr lvl="4"/>
             <a:r>
-              <a:rPr lang="en-US" smtClean="0"/>
+              <a:rPr lang="en-US"/>
               <a:t>Fifth level</a:t>
             </a:r>
-            <a:endParaRPr lang="en-US"/>
           </a:p>
         </p:txBody>
       </p:sp>
@@ -1296,38 +1301,37 @@
           <a:p>
             <a:pPr lvl="0"/>
             <a:r>
-              <a:rPr lang="en-US" smtClean="0"/>
+              <a:rPr lang="en-US"/>
               <a:t>Click to edit Master text styles</a:t>
             </a:r>
           </a:p>
           <a:p>
             <a:pPr lvl="1"/>
             <a:r>
-              <a:rPr lang="en-US" smtClean="0"/>
+              <a:rPr lang="en-US"/>
               <a:t>Second level</a:t>
             </a:r>
           </a:p>
           <a:p>
             <a:pPr lvl="2"/>
             <a:r>
-              <a:rPr lang="en-US" smtClean="0"/>
+              <a:rPr lang="en-US"/>
               <a:t>Third level</a:t>
             </a:r>
           </a:p>
           <a:p>
             <a:pPr lvl="3"/>
             <a:r>
-              <a:rPr lang="en-US" smtClean="0"/>
+              <a:rPr lang="en-US"/>
               <a:t>Fourth level</a:t>
             </a:r>
           </a:p>
           <a:p>
             <a:pPr lvl="4"/>
             <a:r>
-              <a:rPr lang="en-US" smtClean="0"/>
+              <a:rPr lang="en-US"/>
               <a:t>Fifth level</a:t>
             </a:r>
-            <a:endParaRPr lang="en-US"/>
           </a:p>
         </p:txBody>
       </p:sp>
@@ -1348,7 +1352,7 @@
           <a:p>
             <a:fld id="{5BCAD085-E8A6-8845-BD4E-CB4CCA059FC4}" type="datetimeFigureOut">
               <a:rPr lang="en-US" smtClean="0"/>
-              <a:t>1/27/13</a:t>
+              <a:t>10/19/2026</a:t>
             </a:fld>
             <a:endParaRPr lang="en-US"/>
           </a:p>
@@ -1446,10 +1450,9 @@
           </a:lstStyle>
           <a:p>
             <a:r>
-              <a:rPr lang="en-US" smtClean="0"/>
+              <a:rPr lang="en-US"/>
               <a:t>Click to edit Master title style</a:t>
             </a:r>
-            <a:endParaRPr lang="en-US"/>
           </a:p>
         </p:txBody>
       </p:sp>
@@ -1512,7 +1515,7 @@
           <a:p>
             <a:pPr lvl="0"/>
             <a:r>
-              <a:rPr lang="en-US" smtClean="0"/>
+              <a:rPr lang="en-US"/>
               <a:t>Click to edit Master text styles</a:t>
             </a:r>
           </a:p>
@@ -1568,38 +1571,37 @@
           <a:p>
             <a:pPr lvl="0"/>
             <a:r>
-              <a:rPr lang="en-US" smtClean="0"/>
+              <a:rPr lang="en-US"/>
               <a:t>Click to edit Master text styles</a:t>
             </a:r>
           </a:p>
           <a:p>
             <a:pPr lvl="1"/>
             <a:r>
-              <a:rPr lang="en-US" smtClean="0"/>
+              <a:rPr lang="en-US"/>
               <a:t>Second level</a:t>
             </a:r>
           </a:p>
           <a:p>
             <a:pPr lvl="2"/>
             <a:r>
-              <a:rPr lang="en-US" smtClean="0"/>
+              <a:rPr lang="en-US"/>
               <a:t>Third level</a:t>
             </a:r>
           </a:p>
           <a:p>
             <a:pPr lvl="3"/>
             <a:r>
-              <a:rPr lang="en-US" smtClean="0"/>
+              <a:rPr lang="en-US"/>
               <a:t>Fourth level</a:t>
             </a:r>
           </a:p>
           <a:p>
             <a:pPr lvl="4"/>
             <a:r>
-              <a:rPr lang="en-US" smtClean="0"/>
+              <a:rPr lang="en-US"/>
               <a:t>Fifth level</a:t>
             </a:r>
-            <a:endParaRPr lang="en-US"/>
           </a:p>
         </p:txBody>
       </p:sp>
@@ -1662,7 +1664,7 @@
           <a:p>
             <a:pPr lvl="0"/>
             <a:r>
-              <a:rPr lang="en-US" smtClean="0"/>
+              <a:rPr lang="en-US"/>
               <a:t>Click to edit Master text styles</a:t>
             </a:r>
           </a:p>
@@ -1718,38 +1720,37 @@
           <a:p>
             <a:pPr lvl="0"/>
             <a:r>
-              <a:rPr lang="en-US" smtClean="0"/>
+              <a:rPr lang="en-US"/>
               <a:t>Click to edit Master text styles</a:t>
             </a:r>
           </a:p>
           <a:p>
             <a:pPr lvl="1"/>
             <a:r>
-              <a:rPr lang="en-US" smtClean="0"/>
+              <a:rPr lang="en-US"/>
               <a:t>Second level</a:t>
             </a:r>
           </a:p>
           <a:p>
             <a:pPr lvl="2"/>
             <a:r>
-              <a:rPr lang="en-US" smtClean="0"/>
+              <a:rPr lang="en-US"/>
               <a:t>Third level</a:t>
             </a:r>
           </a:p>
           <a:p>
             <a:pPr lvl="3"/>
             <a:r>
-              <a:rPr lang="en-US" smtClean="0"/>
+              <a:rPr lang="en-US"/>
               <a:t>Fourth level</a:t>
             </a:r>
           </a:p>
           <a:p>
             <a:pPr lvl="4"/>
             <a:r>
-              <a:rPr lang="en-US" smtClean="0"/>
+              <a:rPr lang="en-US"/>
               <a:t>Fifth level</a:t>
             </a:r>
-            <a:endParaRPr lang="en-US"/>
           </a:p>
         </p:txBody>
       </p:sp>
@@ -1770,7 +1771,7 @@
           <a:p>
             <a:fld id="{5BCAD085-E8A6-8845-BD4E-CB4CCA059FC4}" type="datetimeFigureOut">
               <a:rPr lang="en-US" smtClean="0"/>
-              <a:t>1/27/13</a:t>
+              <a:t>10/19/2026</a:t>
             </a:fld>
             <a:endParaRPr lang="en-US"/>
           </a:p>
@@ -1864,10 +1865,9 @@
           <a:lstStyle/>
           <a:p>
             <a:r>
-              <a:rPr lang="en-US" smtClean="0"/>
+              <a:rPr lang="en-US"/>
               <a:t>Click to edit Master title style</a:t>
             </a:r>
-            <a:endParaRPr lang="en-US"/>
           </a:p>
         </p:txBody>
       </p:sp>
@@ -1888,7 +1888,7 @@
           <a:p>
             <a:fld id="{5BCAD085-E8A6-8845-BD4E-CB4CCA059FC4}" type="datetimeFigureOut">
               <a:rPr lang="en-US" smtClean="0"/>
-              <a:t>1/27/13</a:t>
+              <a:t>10/19/2026</a:t>
             </a:fld>
             <a:endParaRPr lang="en-US"/>
           </a:p>
@@ -1983,7 +1983,7 @@
           <a:p>
             <a:fld id="{5BCAD085-E8A6-8845-BD4E-CB4CCA059FC4}" type="datetimeFigureOut">
               <a:rPr lang="en-US" smtClean="0"/>
-              <a:t>1/27/13</a:t>
+              <a:t>10/19/2026</a:t>
             </a:fld>
             <a:endParaRPr lang="en-US"/>
           </a:p>
@@ -2086,10 +2086,9 @@
           </a:lstStyle>
           <a:p>
             <a:r>
-              <a:rPr lang="en-US" smtClean="0"/>
+              <a:rPr lang="en-US"/>
               <a:t>Click to edit Master title style</a:t>
             </a:r>
-            <a:endParaRPr lang="en-US"/>
           </a:p>
         </p:txBody>
       </p:sp>
@@ -2143,38 +2142,37 @@
           <a:p>
             <a:pPr lvl="0"/>
             <a:r>
-              <a:rPr lang="en-US" smtClean="0"/>
+              <a:rPr lang="en-US"/>
               <a:t>Click to edit Master text styles</a:t>
             </a:r>
           </a:p>
           <a:p>
             <a:pPr lvl="1"/>
             <a:r>
-              <a:rPr lang="en-US" smtClean="0"/>
+              <a:rPr lang="en-US"/>
               <a:t>Second level</a:t>
             </a:r>
           </a:p>
           <a:p>
             <a:pPr lvl="2"/>
             <a:r>
-              <a:rPr lang="en-US" smtClean="0"/>
+              <a:rPr lang="en-US"/>
               <a:t>Third level</a:t>
             </a:r>
           </a:p>
           <a:p>
             <a:pPr lvl="3"/>
             <a:r>
-              <a:rPr lang="en-US" smtClean="0"/>
+              <a:rPr lang="en-US"/>
               <a:t>Fourth level</a:t>
             </a:r>
           </a:p>
           <a:p>
             <a:pPr lvl="4"/>
             <a:r>
-              <a:rPr lang="en-US" smtClean="0"/>
+              <a:rPr lang="en-US"/>
               <a:t>Fifth level</a:t>
             </a:r>
-            <a:endParaRPr lang="en-US"/>
           </a:p>
         </p:txBody>
       </p:sp>
@@ -2237,7 +2235,7 @@
           <a:p>
             <a:pPr lvl="0"/>
             <a:r>
-              <a:rPr lang="en-US" smtClean="0"/>
+              <a:rPr lang="en-US"/>
               <a:t>Click to edit Master text styles</a:t>
             </a:r>
           </a:p>
@@ -2260,7 +2258,7 @@
           <a:p>
             <a:fld id="{5BCAD085-E8A6-8845-BD4E-CB4CCA059FC4}" type="datetimeFigureOut">
               <a:rPr lang="en-US" smtClean="0"/>
-              <a:t>1/27/13</a:t>
+              <a:t>10/19/2026</a:t>
             </a:fld>
             <a:endParaRPr lang="en-US"/>
           </a:p>
@@ -2363,10 +2361,9 @@
           </a:lstStyle>
           <a:p>
             <a:r>
-              <a:rPr lang="en-US" smtClean="0"/>
+              <a:rPr lang="en-US"/>
               <a:t>Click to edit Master title style</a:t>
             </a:r>
-            <a:endParaRPr lang="en-US"/>
           </a:p>
         </p:txBody>
       </p:sp>
@@ -2490,7 +2487,7 @@
           <a:p>
             <a:pPr lvl="0"/>
             <a:r>
-              <a:rPr lang="en-US" smtClean="0"/>
+              <a:rPr lang="en-US"/>
               <a:t>Click to edit Master text styles</a:t>
             </a:r>
           </a:p>
@@ -2513,7 +2510,7 @@
           <a:p>
             <a:fld id="{5BCAD085-E8A6-8845-BD4E-CB4CCA059FC4}" type="datetimeFigureOut">
               <a:rPr lang="en-US" smtClean="0"/>
-              <a:t>1/27/13</a:t>
+              <a:t>10/19/2026</a:t>
             </a:fld>
             <a:endParaRPr lang="en-US"/>
           </a:p>
@@ -2622,10 +2619,9 @@
           <a:lstStyle/>
           <a:p>
             <a:r>
-              <a:rPr lang="en-US" smtClean="0"/>
+              <a:rPr lang="en-US"/>
               <a:t>Click to edit Master title style</a:t>
             </a:r>
-            <a:endParaRPr lang="en-US"/>
           </a:p>
         </p:txBody>
       </p:sp>
@@ -2656,38 +2652,37 @@
           <a:p>
             <a:pPr lvl="0"/>
             <a:r>
-              <a:rPr lang="en-US" smtClean="0"/>
+              <a:rPr lang="en-US"/>
               <a:t>Click to edit Master text styles</a:t>
             </a:r>
           </a:p>
           <a:p>
             <a:pPr lvl="1"/>
             <a:r>
-              <a:rPr lang="en-US" smtClean="0"/>
+              <a:rPr lang="en-US"/>
               <a:t>Second level</a:t>
             </a:r>
           </a:p>
           <a:p>
             <a:pPr lvl="2"/>
             <a:r>
-              <a:rPr lang="en-US" smtClean="0"/>
+              <a:rPr lang="en-US"/>
               <a:t>Third level</a:t>
             </a:r>
           </a:p>
           <a:p>
             <a:pPr lvl="3"/>
             <a:r>
-              <a:rPr lang="en-US" smtClean="0"/>
+              <a:rPr lang="en-US"/>
               <a:t>Fourth level</a:t>
             </a:r>
           </a:p>
           <a:p>
             <a:pPr lvl="4"/>
             <a:r>
-              <a:rPr lang="en-US" smtClean="0"/>
+              <a:rPr lang="en-US"/>
               <a:t>Fifth level</a:t>
             </a:r>
-            <a:endParaRPr lang="en-US"/>
           </a:p>
         </p:txBody>
       </p:sp>
@@ -2726,7 +2721,7 @@
           <a:p>
             <a:fld id="{5BCAD085-E8A6-8845-BD4E-CB4CCA059FC4}" type="datetimeFigureOut">
               <a:rPr lang="en-US" smtClean="0"/>
-              <a:t>1/27/13</a:t>
+              <a:t>10/19/2026</a:t>
             </a:fld>
             <a:endParaRPr lang="en-US"/>
           </a:p>
@@ -3085,7 +3080,7 @@
 </file>
 
 <file path=ppt/slides/slide1.xml><?xml version="1.0" encoding="utf-8"?>
-<p:sld xmlns:a="http://schemas.openxmlformats.org/drawingml/2006/main" xmlns:p="http://schemas.openxmlformats.org/presentationml/2006/main" xmlns:r="http://schemas.openxmlformats.org/officeDocument/2006/relationships">
+<p:sld xmlns:a="http://schemas.openxmlformats.org/drawingml/2006/main" xmlns:r="http://schemas.openxmlformats.org/officeDocument/2006/relationships" xmlns:p="http://schemas.openxmlformats.org/presentationml/2006/main">
   <p:cSld>
     <p:spTree>
       <p:nvGrpSpPr>
@@ -3093,7 +3088,14 @@
         <p:cNvGrpSpPr/>
         <p:nvPr/>
       </p:nvGrpSpPr>
-      <p:grpSpPr/>
+      <p:grpSpPr>
+        <a:xfrm>
+          <a:off x="0" y="0"/>
+          <a:ext cx="0" cy="0"/>
+          <a:chOff x="0" y="0"/>
+          <a:chExt cx="0" cy="0"/>
+        </a:xfrm>
+      </p:grpSpPr>
       <p:sp>
         <p:nvSpPr>
           <p:cNvPr id="2" name="Rectangle 1"/>
@@ -3135,6 +3137,7 @@
           <a:lstStyle/>
           <a:p>
             <a:pPr algn="ctr"/>
+            <a:endParaRPr/>
           </a:p>
         </p:txBody>
       </p:sp>
@@ -3209,7 +3212,7 @@
 </file>
 
 <file path=ppt/slides/slide2.xml><?xml version="1.0" encoding="utf-8"?>
-<p:sld xmlns:a="http://schemas.openxmlformats.org/drawingml/2006/main" xmlns:p="http://schemas.openxmlformats.org/presentationml/2006/main" xmlns:r="http://schemas.openxmlformats.org/officeDocument/2006/relationships">
+<p:sld xmlns:a="http://schemas.openxmlformats.org/drawingml/2006/main" xmlns:r="http://schemas.openxmlformats.org/officeDocument/2006/relationships" xmlns:p="http://schemas.openxmlformats.org/presentationml/2006/main">
   <p:cSld>
     <p:spTree>
       <p:nvGrpSpPr>
@@ -3217,7 +3220,14 @@
         <p:cNvGrpSpPr/>
         <p:nvPr/>
       </p:nvGrpSpPr>
-      <p:grpSpPr/>
+      <p:grpSpPr>
+        <a:xfrm>
+          <a:off x="0" y="0"/>
+          <a:ext cx="0" cy="0"/>
+          <a:chOff x="0" y="0"/>
+          <a:chExt cx="0" cy="0"/>
+        </a:xfrm>
+      </p:grpSpPr>
       <p:sp>
         <p:nvSpPr>
           <p:cNvPr id="2" name="TextBox 1"/>
@@ -3294,6 +3304,7 @@
           <a:lstStyle/>
           <a:p>
             <a:pPr algn="ctr"/>
+            <a:endParaRPr/>
           </a:p>
         </p:txBody>
       </p:sp>
@@ -3570,7 +3581,7 @@
 </file>
 
 <file path=ppt/slides/slide3.xml><?xml version="1.0" encoding="utf-8"?>
-<p:sld xmlns:a="http://schemas.openxmlformats.org/drawingml/2006/main" xmlns:p="http://schemas.openxmlformats.org/presentationml/2006/main" xmlns:r="http://schemas.openxmlformats.org/officeDocument/2006/relationships">
+<p:sld xmlns:a="http://schemas.openxmlformats.org/drawingml/2006/main" xmlns:r="http://schemas.openxmlformats.org/officeDocument/2006/relationships" xmlns:p="http://schemas.openxmlformats.org/presentationml/2006/main">
   <p:cSld>
     <p:spTree>
       <p:nvGrpSpPr>
@@ -3578,7 +3589,14 @@
         <p:cNvGrpSpPr/>
         <p:nvPr/>
       </p:nvGrpSpPr>
-      <p:grpSpPr/>
+      <p:grpSpPr>
+        <a:xfrm>
+          <a:off x="0" y="0"/>
+          <a:ext cx="0" cy="0"/>
+          <a:chOff x="0" y="0"/>
+          <a:chExt cx="0" cy="0"/>
+        </a:xfrm>
+      </p:grpSpPr>
       <p:sp>
         <p:nvSpPr>
           <p:cNvPr id="2" name="TextBox 1"/>
@@ -3655,6 +3673,7 @@
           <a:lstStyle/>
           <a:p>
             <a:pPr algn="ctr"/>
+            <a:endParaRPr/>
           </a:p>
         </p:txBody>
       </p:sp>
@@ -3691,7 +3710,7 @@
 </file>
 
 <file path=ppt/slides/slide4.xml><?xml version="1.0" encoding="utf-8"?>
-<p:sld xmlns:a="http://schemas.openxmlformats.org/drawingml/2006/main" xmlns:p="http://schemas.openxmlformats.org/presentationml/2006/main" xmlns:r="http://schemas.openxmlformats.org/officeDocument/2006/relationships">
+<p:sld xmlns:a="http://schemas.openxmlformats.org/drawingml/2006/main" xmlns:r="http://schemas.openxmlformats.org/officeDocument/2006/relationships" xmlns:p="http://schemas.openxmlformats.org/presentationml/2006/main">
   <p:cSld>
     <p:spTree>
       <p:nvGrpSpPr>
@@ -3699,7 +3718,14 @@
         <p:cNvGrpSpPr/>
         <p:nvPr/>
       </p:nvGrpSpPr>
-      <p:grpSpPr/>
+      <p:grpSpPr>
+        <a:xfrm>
+          <a:off x="0" y="0"/>
+          <a:ext cx="0" cy="0"/>
+          <a:chOff x="0" y="0"/>
+          <a:chExt cx="0" cy="0"/>
+        </a:xfrm>
+      </p:grpSpPr>
       <p:sp>
         <p:nvSpPr>
           <p:cNvPr id="2" name="TextBox 1"/>
@@ -3776,6 +3802,7 @@
           <a:lstStyle/>
           <a:p>
             <a:pPr algn="ctr"/>
+            <a:endParaRPr/>
           </a:p>
         </p:txBody>
       </p:sp>
@@ -3901,7 +3928,7 @@
 </file>
 
 <file path=ppt/slides/slide5.xml><?xml version="1.0" encoding="utf-8"?>
-<p:sld xmlns:a="http://schemas.openxmlformats.org/drawingml/2006/main" xmlns:p="http://schemas.openxmlformats.org/presentationml/2006/main" xmlns:r="http://schemas.openxmlformats.org/officeDocument/2006/relationships">
+<p:sld xmlns:a="http://schemas.openxmlformats.org/drawingml/2006/main" xmlns:r="http://schemas.openxmlformats.org/officeDocument/2006/relationships" xmlns:p="http://schemas.openxmlformats.org/presentationml/2006/main">
   <p:cSld>
     <p:spTree>
       <p:nvGrpSpPr>
@@ -3909,7 +3936,14 @@
         <p:cNvGrpSpPr/>
         <p:nvPr/>
       </p:nvGrpSpPr>
-      <p:grpSpPr/>
+      <p:grpSpPr>
+        <a:xfrm>
+          <a:off x="0" y="0"/>
+          <a:ext cx="0" cy="0"/>
+          <a:chOff x="0" y="0"/>
+          <a:chExt cx="0" cy="0"/>
+        </a:xfrm>
+      </p:grpSpPr>
       <p:sp>
         <p:nvSpPr>
           <p:cNvPr id="2" name="TextBox 1"/>
@@ -3986,6 +4020,7 @@
           <a:lstStyle/>
           <a:p>
             <a:pPr algn="ctr"/>
+            <a:endParaRPr/>
           </a:p>
         </p:txBody>
       </p:sp>
@@ -4144,7 +4179,7 @@
           </a:fontRef>
         </p:style>
         <p:txBody>
-          <a:bodyPr rtlCol="0" anchor="ctr" wrap="square" lIns="228600" rIns="228600" tIns="109728" bIns="109728"/>
+          <a:bodyPr wrap="square" lIns="228600" tIns="109728" rIns="228600" bIns="109728" rtlCol="0" anchor="ctr"/>
           <a:lstStyle/>
           <a:p>
             <a:pPr algn="ctr">
@@ -4187,7 +4222,7 @@
 </file>
 
 <file path=ppt/slides/slide6.xml><?xml version="1.0" encoding="utf-8"?>
-<p:sld xmlns:a="http://schemas.openxmlformats.org/drawingml/2006/main" xmlns:p="http://schemas.openxmlformats.org/presentationml/2006/main" xmlns:r="http://schemas.openxmlformats.org/officeDocument/2006/relationships">
+<p:sld xmlns:a="http://schemas.openxmlformats.org/drawingml/2006/main" xmlns:r="http://schemas.openxmlformats.org/officeDocument/2006/relationships" xmlns:p="http://schemas.openxmlformats.org/presentationml/2006/main">
   <p:cSld>
     <p:spTree>
       <p:nvGrpSpPr>
@@ -4195,7 +4230,14 @@
         <p:cNvGrpSpPr/>
         <p:nvPr/>
       </p:nvGrpSpPr>
-      <p:grpSpPr/>
+      <p:grpSpPr>
+        <a:xfrm>
+          <a:off x="0" y="0"/>
+          <a:ext cx="0" cy="0"/>
+          <a:chOff x="0" y="0"/>
+          <a:chExt cx="0" cy="0"/>
+        </a:xfrm>
+      </p:grpSpPr>
       <p:sp>
         <p:nvSpPr>
           <p:cNvPr id="2" name="TextBox 1"/>
@@ -4272,6 +4314,7 @@
           <a:lstStyle/>
           <a:p>
             <a:pPr algn="ctr"/>
+            <a:endParaRPr/>
           </a:p>
         </p:txBody>
       </p:sp>
@@ -4455,7 +4498,7 @@
           </a:fontRef>
         </p:style>
         <p:txBody>
-          <a:bodyPr rtlCol="0" anchor="ctr" wrap="square" lIns="228600" rIns="228600" tIns="109728" bIns="109728"/>
+          <a:bodyPr wrap="square" lIns="228600" tIns="109728" rIns="228600" bIns="109728" rtlCol="0" anchor="ctr"/>
           <a:lstStyle/>
           <a:p>
             <a:pPr algn="ctr">
@@ -4469,23 +4512,34 @@
               </a:defRPr>
             </a:pPr>
             <a:r>
-              <a:t>$13,793,557 real stressed loss</a:t>
-            </a:r>
-          </a:p>
-          <a:p>
-            <a:pPr>
+              <a:rPr lang="en-IN" sz="2400" b="1" dirty="0">
+                <a:solidFill>
+                  <a:srgbClr val="0B0B0B"/>
+                </a:solidFill>
+              </a:rPr>
+              <a:t>$13.79M stressed loss (−2.09%)</a:t>
+            </a:r>
+          </a:p>
+          <a:p>
+            <a:pPr algn="ctr">
               <a:spcAft>
                 <a:spcPts val="400"/>
               </a:spcAft>
-              <a:defRPr sz="1500" b="0">
+              <a:defRPr sz="2400" b="1">
                 <a:solidFill>
                   <a:srgbClr val="0B0B0B"/>
                 </a:solidFill>
               </a:defRPr>
             </a:pPr>
             <a:r>
-              <a:t>2.09% of portfolio value, from one real headline</a:t>
-            </a:r>
+              <a:rPr lang="en-IN" sz="1400" dirty="0">
+                <a:solidFill>
+                  <a:srgbClr val="0B0B0B"/>
+                </a:solidFill>
+              </a:rPr>
+              <a:t>Fed severely-adverse scenario on the synthetic portfolio, triggered by a real headline</a:t>
+            </a:r>
+            <a:endParaRPr sz="1400" dirty="0"/>
           </a:p>
         </p:txBody>
       </p:sp>
@@ -4498,7 +4552,7 @@
 </file>
 
 <file path=ppt/slides/slide7.xml><?xml version="1.0" encoding="utf-8"?>
-<p:sld xmlns:a="http://schemas.openxmlformats.org/drawingml/2006/main" xmlns:p="http://schemas.openxmlformats.org/presentationml/2006/main" xmlns:r="http://schemas.openxmlformats.org/officeDocument/2006/relationships">
+<p:sld xmlns:a="http://schemas.openxmlformats.org/drawingml/2006/main" xmlns:r="http://schemas.openxmlformats.org/officeDocument/2006/relationships" xmlns:p="http://schemas.openxmlformats.org/presentationml/2006/main">
   <p:cSld>
     <p:spTree>
       <p:nvGrpSpPr>
@@ -4506,7 +4560,14 @@
         <p:cNvGrpSpPr/>
         <p:nvPr/>
       </p:nvGrpSpPr>
-      <p:grpSpPr/>
+      <p:grpSpPr>
+        <a:xfrm>
+          <a:off x="0" y="0"/>
+          <a:ext cx="0" cy="0"/>
+          <a:chOff x="0" y="0"/>
+          <a:chExt cx="0" cy="0"/>
+        </a:xfrm>
+      </p:grpSpPr>
       <p:sp>
         <p:nvSpPr>
           <p:cNvPr id="2" name="TextBox 1"/>
@@ -4583,6 +4644,7 @@
           <a:lstStyle/>
           <a:p>
             <a:pPr algn="ctr"/>
+            <a:endParaRPr/>
           </a:p>
         </p:txBody>
       </p:sp>

</xml_diff>